<commit_message>
Add period filter and official cross-checks
- Pick any period (presets or custom months); levels, flags, map and table recompute without a new satellite run; CSV for the period
- Validate against Mahagenco and NTPC compliance filings: Chandrapur stack SO2 ~6x the limit, Koradi has no scrubber, Mauda Stage II scrubbers in service
- Scrubber check now compares with every plant without a scrubber; adds a partial-scrubbing verdict
- Clearer headline; slides updated with the official checks

Co-Authored-By: Claude Opus 5.5 <noreply@anthropic.com>
</commit_message>
<xml_diff>
--- a/presentation/Udyog-drishti_AI_Seva_2026.pptx
+++ b/presentation/Udyog-drishti_AI_Seva_2026.pptx
@@ -1212,7 +1212,7 @@
                 <a:ea typeface="Nirmala UI" pitchFamily="34" charset="-122"/>
                 <a:cs typeface="Nirmala UI" pitchFamily="34" charset="-120"/>
               </a:rPr>
-              <a:t>Every big chimney in Maharashtra, checked from space each month: where to inspect first, and whether a scrubber worked. Independent of the plants' own monitors.</a:t>
+              <a:t>A monthly satellite check of SO₂ and NO₂ at Maharashtra's large coal power plants and industrial areas: where to inspect first, and whether a scrubber worked. Independent of the plants' own monitors.</a:t>
             </a:r>
             <a:endParaRPr lang="en-US" sz="1200" dirty="0"/>
           </a:p>
@@ -1480,7 +1480,7 @@
                 </a:solidFill>
                 <a:latin typeface="Nirmala UI"/>
               </a:rPr>
-              <a:t>• Sentinel-5P SO₂ and NO₂; spotted NTPC Mauda's scrubber</a:t>
+              <a:t>• Sentinel-5P SO₂ and NO₂; agrees with plants' official filings</a:t>
             </a:r>
           </a:p>
           <a:p>
@@ -2156,7 +2156,7 @@
                 <a:ea typeface="Nirmala UI" pitchFamily="34" charset="-122"/>
                 <a:cs typeface="Nirmala UI" pitchFamily="34" charset="-120"/>
               </a:rPr>
-              <a:t>Chandrapur and Koradi</a:t>
+              <a:t>Chandrapur</a:t>
             </a:r>
             <a:r>
               <a:rPr lang="en-US" sz="950" i="0" dirty="0" b="0">
@@ -2167,7 +2167,29 @@
                 <a:ea typeface="Nirmala UI" pitchFamily="34" charset="-122"/>
                 <a:cs typeface="Nirmala UI" pitchFamily="34" charset="-120"/>
               </a:rPr>
-              <a:t>: among India's top SO₂ hotspots in NASA data</a:t>
+              <a:t>: own stack reports show SO₂ </a:t>
+            </a:r>
+            <a:r>
+              <a:rPr lang="en-US" sz="950" i="0" dirty="0" b="1">
+                <a:solidFill>
+                  <a:srgbClr val="1F2937"/>
+                </a:solidFill>
+                <a:latin typeface="Nirmala UI" pitchFamily="34" charset="0"/>
+                <a:ea typeface="Nirmala UI" pitchFamily="34" charset="-122"/>
+                <a:cs typeface="Nirmala UI" pitchFamily="34" charset="-120"/>
+              </a:rPr>
+              <a:t>~6× the limit</a:t>
+            </a:r>
+            <a:r>
+              <a:rPr lang="en-US" sz="950" i="0" dirty="0" b="0">
+                <a:solidFill>
+                  <a:srgbClr val="1F2937"/>
+                </a:solidFill>
+                <a:latin typeface="Nirmala UI" pitchFamily="34" charset="0"/>
+                <a:ea typeface="Nirmala UI" pitchFamily="34" charset="-122"/>
+                <a:cs typeface="Nirmala UI" pitchFamily="34" charset="-120"/>
+              </a:rPr>
+              <a:t> (2024–26)</a:t>
             </a:r>
           </a:p>
           <a:p>
@@ -2627,7 +2649,7 @@
                 </a:solidFill>
                 <a:latin typeface="Nirmala UI"/>
               </a:rPr>
-              <a:t>Sources: MoEFCC notification, 11 Jul 2025; Greenpeace analysis of NASA OMI data; TechTimes analysis of CPCB data, Aug 2026; CEEW 2024 and CSE on OCEMS; CREA, Jul 2026.</a:t>
+              <a:t>Sources: MoEFCC notification, 11 Jul 2025; Mahagenco CSTPS EC compliance reports to MoEF&amp;CC, 2024–26; TechTimes analysis of CPCB data, Aug 2026; CEEW 2024 and CSE on OCEMS; CREA, Jul 2026.</a:t>
             </a:r>
           </a:p>
         </p:txBody>
@@ -4871,7 +4893,7 @@
                 <a:ea typeface="Nirmala UI" pitchFamily="34" charset="-122"/>
                 <a:cs typeface="Nirmala UI" pitchFamily="34" charset="-120"/>
               </a:rPr>
-              <a:t>Does not rely on the polluter's own data. It spotted the scrubber at </a:t>
+              <a:t>Independent of the polluter's data, yet it agrees with official filings: </a:t>
             </a:r>
             <a:r>
               <a:rPr lang="en-US" sz="950" i="0" dirty="0" b="1">
@@ -4882,7 +4904,7 @@
                 <a:ea typeface="Nirmala UI" pitchFamily="34" charset="-122"/>
                 <a:cs typeface="Nirmala UI" pitchFamily="34" charset="-120"/>
               </a:rPr>
-              <a:t>NTPC Mauda</a:t>
+              <a:t>Chandrapur</a:t>
             </a:r>
             <a:r>
               <a:rPr lang="en-US" sz="950" i="0" dirty="0" b="0">
@@ -4893,7 +4915,7 @@
                 <a:ea typeface="Nirmala UI" pitchFamily="34" charset="-122"/>
                 <a:cs typeface="Nirmala UI" pitchFamily="34" charset="-120"/>
               </a:rPr>
-              <a:t> from space: SO₂ ÷ NO₂ fell </a:t>
+              <a:t> (flagged here) reports SO₂ ~6× the limit; </a:t>
             </a:r>
             <a:r>
               <a:rPr lang="en-US" sz="950" i="0" dirty="0" b="1">
@@ -4904,7 +4926,7 @@
                 <a:ea typeface="Nirmala UI" pitchFamily="34" charset="-122"/>
                 <a:cs typeface="Nirmala UI" pitchFamily="34" charset="-120"/>
               </a:rPr>
-              <a:t>38%</a:t>
+              <a:t>Mauda's</a:t>
             </a:r>
             <a:r>
               <a:rPr lang="en-US" sz="950" i="0" dirty="0" b="0">
@@ -4915,7 +4937,7 @@
                 <a:ea typeface="Nirmala UI" pitchFamily="34" charset="-122"/>
                 <a:cs typeface="Nirmala UI" pitchFamily="34" charset="-120"/>
               </a:rPr>
-              <a:t> since 2025 vs 8% at exempt plants. Mauda's FGD was then confirmed in service.</a:t>
+              <a:t> SO₂ ÷ NO₂ fell 38% vs 14% at unscrubbed plants, and NTPC confirms its scrubbers.</a:t>
             </a:r>
             <a:endParaRPr lang="en-US" sz="1000" dirty="0"/>
           </a:p>
@@ -7083,7 +7105,7 @@
                 <a:ea typeface="Nirmala UI" pitchFamily="34" charset="-122"/>
                 <a:cs typeface="Nirmala UI" pitchFamily="34" charset="-120"/>
               </a:rPr>
-              <a:t>−30%</a:t>
+              <a:t>3 of 3</a:t>
             </a:r>
             <a:endParaRPr lang="en-US" sz="3000" dirty="0"/>
           </a:p>
@@ -7125,7 +7147,7 @@
                 <a:ea typeface="Nirmala UI" pitchFamily="34" charset="-122"/>
                 <a:cs typeface="Nirmala UI" pitchFamily="34" charset="-120"/>
               </a:rPr>
-              <a:t>Scrubber seen from space</a:t>
+              <a:t>Checks vs official filings</a:t>
             </a:r>
             <a:endParaRPr lang="en-US" sz="1100" dirty="0"/>
           </a:p>
@@ -7167,7 +7189,7 @@
                 <a:ea typeface="Nirmala UI" pitchFamily="34" charset="-122"/>
                 <a:cs typeface="Nirmala UI" pitchFamily="34" charset="-120"/>
               </a:rPr>
-              <a:t>NTPC Mauda, SO₂ ÷ NO₂ vs exempt plants</a:t>
+              <a:t>Chandrapur, Koradi, Mauda agree with stack and scrubber records</a:t>
             </a:r>
             <a:endParaRPr lang="en-US" sz="900" dirty="0"/>
           </a:p>
@@ -7662,7 +7684,7 @@
                 </a:solidFill>
                 <a:latin typeface="Nirmala UI"/>
               </a:rPr>
-              <a:t>Sources: Global Power Plant Database (capacity); Udyog-drishti run, Jan 2019–Sep 2026; The Live Nagpur, 23 Oct 2026 (Mauda FGD in service). Server cost is an estimate.</a:t>
+              <a:t>Sources: Global Power Plant Database (capacity); Udyog-drishti run, Jan 2019–Sep 2026; Mahagenco and NTPC EC compliance reports to MoEF&amp;CC (2024–26). Server cost is an estimate.</a:t>
             </a:r>
           </a:p>
         </p:txBody>

</xml_diff>